<commit_message>
RA vs OA deck: add Tang 2025 Nat Rev Dis Primers osteoarthritis reference
- Add Tang S, et al. Osteoarthritis. Nat Rev Dis Primers. 2025;11(1):10 to bibliography
- Cite it on the OA-diagnosis and inflammatory-OA slides

Co-Authored-By: Claude Opus 4.8 <noreply@anthropic.com>
Claude-Session: https://claude.ai/code/session_01Xvkr5H24hZZBXgabDYzMMQ
</commit_message>
<xml_diff>
--- a/Dx_AR_vs_artrosis.pptx
+++ b/Dx_AR_vs_artrosis.pptx
@@ -7993,7 +7993,7 @@
                 <a:ea typeface="Calibri" pitchFamily="34" charset="-122"/>
                 <a:cs typeface="Calibri" pitchFamily="34" charset="-120"/>
               </a:rPr>
-              <a:t>12. van Steenbergen HW, Aletaha D, Beaart-van de Voorde LJJ, Brouwer E, Codreanu C, Combe B, et al. EULAR definition of arthralgia suspicious for progression to rheumatoid arthritis. Ann Rheum Dis. 2017;76(3):491-6.</a:t>
+              <a:t>13. van Steenbergen HW, Aletaha D, Beaart-van de Voorde LJJ, Brouwer E, Codreanu C, Combe B, et al. EULAR definition of arthralgia suspicious for progression to rheumatoid arthritis. Ann Rheum Dis. 2017;76(3):491-6.</a:t>
             </a:r>
             <a:endParaRPr lang="en-US" sz="900" dirty="0"/>
           </a:p>
@@ -9355,7 +9355,7 @@
                 <a:ea typeface="Calibri" pitchFamily="34" charset="-122"/>
                 <a:cs typeface="Calibri" pitchFamily="34" charset="-120"/>
               </a:rPr>
-              <a:t>8. Kolasinski SL, Neogi T, Hochberg MC, Oatis C, Guyatt G, Block J, et al. 2019 ACR/Arthritis Foundation guideline for the management of osteoarthritis of the hand, hip, and knee. Arthritis Rheumatol. 2020;72(2):220-33.</a:t>
+              <a:t>8. Tang S, Zhang C, Oo WM, Fu K, Risberg MA, Bierma-Zeinstra SM, et al. Osteoarthritis. Nat Rev Dis Primers. 2025;11(1):10.</a:t>
             </a:r>
             <a:endParaRPr lang="en-US" sz="900" dirty="0"/>
           </a:p>
@@ -10001,7 +10001,7 @@
                 <a:ea typeface="Calibri" pitchFamily="34" charset="-122"/>
                 <a:cs typeface="Calibri" pitchFamily="34" charset="-120"/>
               </a:rPr>
-              <a:t>10. Dell’Isola A, Allan R, Smith SL, Marreiros SS, Steultjens M. Identification of clinical phenotypes in knee osteoarthritis: a systematic review of the literature. BMC Musculoskelet Disord. 2016;17:425.</a:t>
+              <a:t>11. Dell’Isola A, Allan R, Smith SL, Marreiros SS, Steultjens M. Identification of clinical phenotypes in knee osteoarthritis: a systematic review of the literature. BMC Musculoskelet Disord. 2016;17:425.</a:t>
             </a:r>
             <a:endParaRPr lang="en-US" sz="900" dirty="0"/>
           </a:p>
@@ -10018,7 +10018,7 @@
                 <a:ea typeface="Calibri" pitchFamily="34" charset="-122"/>
                 <a:cs typeface="Calibri" pitchFamily="34" charset="-120"/>
               </a:rPr>
-              <a:t>11. Deveza LA, Nelson AE, Loeser RF. Phenotypes of osteoarthritis: current state and future implications. Clin Exp Rheumatol. 2019;37 Suppl 120(5):S64-72.</a:t>
+              <a:t>12. Deveza LA, Nelson AE, Loeser RF. Phenotypes of osteoarthritis: current state and future implications. Clin Exp Rheumatol. 2019;37 Suppl 120(5):S64-72.</a:t>
             </a:r>
             <a:endParaRPr lang="en-US" sz="900" dirty="0"/>
           </a:p>
@@ -11267,24 +11267,24 @@
                 <a:ea typeface="Calibri" pitchFamily="34" charset="-122"/>
                 <a:cs typeface="Calibri" pitchFamily="34" charset="-120"/>
               </a:rPr>
+              <a:t>8. Tang S, Zhang C, Oo WM, Fu K, Risberg MA, Bierma-Zeinstra SM, et al. Osteoarthritis. Nat Rev Dis Primers. 2025;11(1):10.</a:t>
+            </a:r>
+            <a:endParaRPr lang="en-US" sz="900" dirty="0"/>
+          </a:p>
+          <a:p>
+            <a:pPr indent="0" marL="0">
+              <a:buNone/>
+            </a:pPr>
+            <a:r>
+              <a:rPr lang="en-US" sz="900" dirty="0">
+                <a:solidFill>
+                  <a:srgbClr val="141821"/>
+                </a:solidFill>
+                <a:latin typeface="Calibri" pitchFamily="34" charset="0"/>
+                <a:ea typeface="Calibri" pitchFamily="34" charset="-122"/>
+                <a:cs typeface="Calibri" pitchFamily="34" charset="-120"/>
+              </a:rPr>
               <a:t>7. Hunter DJ, Bierma-Zeinstra S. Osteoarthritis. Lancet. 2019;393(10182):1745-59.</a:t>
-            </a:r>
-            <a:endParaRPr lang="en-US" sz="900" dirty="0"/>
-          </a:p>
-          <a:p>
-            <a:pPr indent="0" marL="0">
-              <a:buNone/>
-            </a:pPr>
-            <a:r>
-              <a:rPr lang="en-US" sz="900" dirty="0">
-                <a:solidFill>
-                  <a:srgbClr val="141821"/>
-                </a:solidFill>
-                <a:latin typeface="Calibri" pitchFamily="34" charset="0"/>
-                <a:ea typeface="Calibri" pitchFamily="34" charset="-122"/>
-                <a:cs typeface="Calibri" pitchFamily="34" charset="-120"/>
-              </a:rPr>
-              <a:t>10. Dell’Isola A, Allan R, Smith SL, Marreiros SS, Steultjens M. Identification of clinical phenotypes in knee osteoarthritis: a systematic review of the literature. BMC Musculoskelet Disord. 2016;17:425.</a:t>
             </a:r>
             <a:endParaRPr lang="en-US" sz="900" dirty="0"/>
           </a:p>
@@ -17560,28 +17560,6 @@
             </a:r>
             <a:endParaRPr lang="en-US" sz="950" dirty="0"/>
           </a:p>
-        </p:txBody>
-      </p:sp>
-      <p:sp>
-        <p:nvSpPr>
-          <p:cNvPr id="6" name="Text 4"/>
-          <p:cNvSpPr txBox="1"/>
-          <p:nvPr/>
-        </p:nvSpPr>
-        <p:spPr>
-          <a:xfrm>
-            <a:off x="4709160" y="1234440"/>
-            <a:ext cx="4114800" cy="3154680"/>
-          </a:xfrm>
-          <a:prstGeom prst="rect">
-            <a:avLst/>
-          </a:prstGeom>
-          <a:noFill/>
-          <a:ln/>
-        </p:spPr>
-        <p:txBody>
-          <a:bodyPr wrap="square" lIns="0" tIns="0" rIns="0" bIns="0" rtlCol="0" anchor="t"/>
-          <a:lstStyle/>
           <a:p>
             <a:pPr indent="0" marL="0">
               <a:spcAft>
@@ -17602,6 +17580,28 @@
             </a:r>
             <a:endParaRPr lang="en-US" sz="950" dirty="0"/>
           </a:p>
+        </p:txBody>
+      </p:sp>
+      <p:sp>
+        <p:nvSpPr>
+          <p:cNvPr id="6" name="Text 4"/>
+          <p:cNvSpPr txBox="1"/>
+          <p:nvPr/>
+        </p:nvSpPr>
+        <p:spPr>
+          <a:xfrm>
+            <a:off x="4709160" y="1234440"/>
+            <a:ext cx="4114800" cy="3154680"/>
+          </a:xfrm>
+          <a:prstGeom prst="rect">
+            <a:avLst/>
+          </a:prstGeom>
+          <a:noFill/>
+          <a:ln/>
+        </p:spPr>
+        <p:txBody>
+          <a:bodyPr wrap="square" lIns="0" tIns="0" rIns="0" bIns="0" rtlCol="0" anchor="t"/>
+          <a:lstStyle/>
           <a:p>
             <a:pPr indent="0" marL="0">
               <a:spcAft>
@@ -17618,7 +17618,7 @@
                 <a:ea typeface="Calibri" pitchFamily="34" charset="-122"/>
                 <a:cs typeface="Calibri" pitchFamily="34" charset="-120"/>
               </a:rPr>
-              <a:t>8. Kolasinski SL, Neogi T, Hochberg MC, Oatis C, Guyatt G, Block J, et al. 2019 ACR/Arthritis Foundation guideline for the management of osteoarthritis of the hand, hip, and knee. Arthritis Rheumatol. 2020;72(2):220-33.</a:t>
+              <a:t>8. Tang S, Zhang C, Oo WM, Fu K, Risberg MA, Bierma-Zeinstra SM, et al. Osteoarthritis. Nat Rev Dis Primers. 2025;11(1):10.</a:t>
             </a:r>
             <a:endParaRPr lang="en-US" sz="950" dirty="0"/>
           </a:p>
@@ -17638,7 +17638,7 @@
                 <a:ea typeface="Calibri" pitchFamily="34" charset="-122"/>
                 <a:cs typeface="Calibri" pitchFamily="34" charset="-120"/>
               </a:rPr>
-              <a:t>9. Sharma L. Osteoarthritis of the knee. N Engl J Med. 2021;384(1):51-9.</a:t>
+              <a:t>9. Kolasinski SL, Neogi T, Hochberg MC, Oatis C, Guyatt G, Block J, et al. 2019 ACR/Arthritis Foundation guideline for the management of osteoarthritis of the hand, hip, and knee. Arthritis Rheumatol. 2020;72(2):220-33.</a:t>
             </a:r>
             <a:endParaRPr lang="en-US" sz="950" dirty="0"/>
           </a:p>
@@ -17658,7 +17658,7 @@
                 <a:ea typeface="Calibri" pitchFamily="34" charset="-122"/>
                 <a:cs typeface="Calibri" pitchFamily="34" charset="-120"/>
               </a:rPr>
-              <a:t>10. Dell’Isola A, Allan R, Smith SL, Marreiros SS, Steultjens M. Identification of clinical phenotypes in knee osteoarthritis: a systematic review of the literature. BMC Musculoskelet Disord. 2016;17:425.</a:t>
+              <a:t>10. Sharma L. Osteoarthritis of the knee. N Engl J Med. 2021;384(1):51-9.</a:t>
             </a:r>
             <a:endParaRPr lang="en-US" sz="950" dirty="0"/>
           </a:p>
@@ -17678,7 +17678,7 @@
                 <a:ea typeface="Calibri" pitchFamily="34" charset="-122"/>
                 <a:cs typeface="Calibri" pitchFamily="34" charset="-120"/>
               </a:rPr>
-              <a:t>11. Deveza LA, Nelson AE, Loeser RF. Phenotypes of osteoarthritis: current state and future implications. Clin Exp Rheumatol. 2019;37 Suppl 120(5):S64-72.</a:t>
+              <a:t>11. Dell’Isola A, Allan R, Smith SL, Marreiros SS, Steultjens M. Identification of clinical phenotypes in knee osteoarthritis: a systematic review of the literature. BMC Musculoskelet Disord. 2016;17:425.</a:t>
             </a:r>
             <a:endParaRPr lang="en-US" sz="950" dirty="0"/>
           </a:p>
@@ -17698,7 +17698,27 @@
                 <a:ea typeface="Calibri" pitchFamily="34" charset="-122"/>
                 <a:cs typeface="Calibri" pitchFamily="34" charset="-120"/>
               </a:rPr>
-              <a:t>12. van Steenbergen HW, Aletaha D, Beaart-van de Voorde LJJ, Brouwer E, Codreanu C, Combe B, et al. EULAR definition of arthralgia suspicious for progression to rheumatoid arthritis. Ann Rheum Dis. 2017;76(3):491-6.</a:t>
+              <a:t>12. Deveza LA, Nelson AE, Loeser RF. Phenotypes of osteoarthritis: current state and future implications. Clin Exp Rheumatol. 2019;37 Suppl 120(5):S64-72.</a:t>
+            </a:r>
+            <a:endParaRPr lang="en-US" sz="950" dirty="0"/>
+          </a:p>
+          <a:p>
+            <a:pPr indent="0" marL="0">
+              <a:spcAft>
+                <a:spcPts val="600"/>
+              </a:spcAft>
+              <a:buNone/>
+            </a:pPr>
+            <a:r>
+              <a:rPr lang="en-US" sz="950" dirty="0">
+                <a:solidFill>
+                  <a:srgbClr val="141821"/>
+                </a:solidFill>
+                <a:latin typeface="Calibri" pitchFamily="34" charset="0"/>
+                <a:ea typeface="Calibri" pitchFamily="34" charset="-122"/>
+                <a:cs typeface="Calibri" pitchFamily="34" charset="-120"/>
+              </a:rPr>
+              <a:t>13. van Steenbergen HW, Aletaha D, Beaart-van de Voorde LJJ, Brouwer E, Codreanu C, Combe B, et al. EULAR definition of arthralgia suspicious for progression to rheumatoid arthritis. Ann Rheum Dis. 2017;76(3):491-6.</a:t>
             </a:r>
             <a:endParaRPr lang="en-US" sz="950" dirty="0"/>
           </a:p>

</xml_diff>